<commit_message>
Cut each foot to one 20 pt sentence
The foot of a figure slide is a single statement or it is another paragraph.
It had grown to two to four sentences, which put it back in competition with
the column above it. Each is now one sentence at 20 pt, on one line, carrying
only what the claim needs.

What came out was information the claim does not depend on: the legend gloss on
the absorption figure, the ridge endpoints and the Monte Carlo range already
drawn on the plots, and the definition of u that the x-axis already gives.
Two items that are worth keeping but do not belong in the sentence -- the
lambda*sigma correction and the caveat that the ambient curve is coarse below
50 GPa -- moved down into the 12 pt line rather than out of the deck.

Claims are unchanged; layout check and schema validation are clean.

Co-Authored-By: Claude Opus 5 <noreply@anthropic.com>
Claude-Session: https://claude.ai/code/session_01G8w5ArMbexSrF5VZNHeNqx
</commit_message>
<xml_diff>
--- a/slides/odmr_473nm_talk.pptx
+++ b/slides/odmr_473nm_talk.pptx
@@ -9457,7 +9457,7 @@
         <p:spPr>
           <a:xfrm>
             <a:off x="7726679" y="1371600"/>
-            <a:ext cx="3977639" cy="3840480"/>
+            <a:ext cx="3977639" cy="4160520"/>
           </a:xfrm>
           <a:prstGeom prst="rect">
             <a:avLst/>
@@ -9607,7 +9607,7 @@
                 <a:ea typeface="Yu Gothic"/>
                 <a:cs typeface="Yu Gothic"/>
               </a:rPr>
-              <a:t>未校正の量は docs/next_step_power_dependence_experiment.md の Stage 1–3 で決める。</a:t>
+              <a:t>u = 1 は λopt における NV⁻ 遷移の半飽和強度。未校正の量は docs/next_step_power_dependence_experiment.md の Stage 1–3 で決める。</a:t>
             </a:r>
           </a:p>
         </p:txBody>
@@ -9620,8 +9620,8 @@
         </p:nvSpPr>
         <p:spPr>
           <a:xfrm>
-            <a:off x="502920" y="5358384"/>
-            <a:ext cx="11192256" cy="868680"/>
+            <a:off x="502920" y="5715000"/>
+            <a:ext cx="11192256" cy="411480"/>
           </a:xfrm>
           <a:prstGeom prst="rect">
             <a:avLst/>
@@ -9643,7 +9643,7 @@
               </a:spcAft>
             </a:pPr>
             <a:r>
-              <a:rPr sz="1800" b="0">
+              <a:rPr sz="2000" b="0">
                 <a:solidFill>
                   <a:srgbClr val="101426"/>
                 </a:solidFill>
@@ -9651,10 +9651,10 @@
                 <a:ea typeface="Yu Gothic"/>
                 <a:cs typeface="Yu Gothic"/>
               </a:rPr>
-              <a:t>図: u = 1 は λopt での NV⁻ 遷移の半飽和強度。稜線は 475.5 nm (u→0) から 405 nm のイオン化端まで走る。Dai 2022 の線形 PL が置く u ≲ 0.3 では 473 nm 固定のコストが ×1.51 に達し、</a:t>
-            </a:r>
-            <a:r>
-              <a:rPr sz="1800" b="1">
+              <a:t>既存実験がいる u ≲ 0.3 では 473 nm 固定が ×1.51 になり、</a:t>
+            </a:r>
+            <a:r>
+              <a:rPr sz="2000" b="1">
                 <a:solidFill>
                   <a:srgbClr val="101426"/>
                 </a:solidFill>
@@ -9662,7 +9662,18 @@
                 <a:ea typeface="Yu Gothic"/>
                 <a:cs typeface="Yu Gothic"/>
               </a:rPr>
-              <a:t>緑に対する ×2.5 の大半を食う。</a:t>
+              <a:t>緑への ×2.5 の大半を食う</a:t>
+            </a:r>
+            <a:r>
+              <a:rPr sz="2000" b="0">
+                <a:solidFill>
+                  <a:srgbClr val="101426"/>
+                </a:solidFill>
+                <a:latin typeface="Yu Gothic"/>
+                <a:ea typeface="Yu Gothic"/>
+                <a:cs typeface="Yu Gothic"/>
+              </a:rPr>
+              <a:t>。</a:t>
             </a:r>
           </a:p>
         </p:txBody>
@@ -10990,7 +11001,7 @@
         <p:spPr>
           <a:xfrm>
             <a:off x="7726679" y="1371600"/>
-            <a:ext cx="3977639" cy="3840480"/>
+            <a:ext cx="3977639" cy="4160520"/>
           </a:xfrm>
           <a:prstGeom prst="rect">
             <a:avLst/>
@@ -11150,7 +11161,7 @@
                 <a:ea typeface="Yu Gothic"/>
                 <a:cs typeface="Yu Gothic"/>
               </a:rPr>
-              <a:t>K. O. Ho, C. Dailledouze et al., arXiv:2606.02399 (2026) — DFT + DAC。</a:t>
+              <a:t>K. O. Ho, C. Dailledouze et al., arXiv:2606.02399 (2026) — DFT + DAC。灰色の常圧曲線は単一有効フォノン近似（50 GPa 以下では粗い）。</a:t>
             </a:r>
           </a:p>
         </p:txBody>
@@ -11163,8 +11174,8 @@
         </p:nvSpPr>
         <p:spPr>
           <a:xfrm>
-            <a:off x="502920" y="5358384"/>
-            <a:ext cx="11192256" cy="868680"/>
+            <a:off x="502920" y="5715000"/>
+            <a:ext cx="11192256" cy="411480"/>
           </a:xfrm>
           <a:prstGeom prst="rect">
             <a:avLst/>
@@ -11186,7 +11197,7 @@
               </a:spcAft>
             </a:pPr>
             <a:r>
-              <a:rPr sz="1800" b="0">
+              <a:rPr sz="2000" b="0">
                 <a:solidFill>
                   <a:srgbClr val="101426"/>
                 </a:solidFill>
@@ -11194,10 +11205,10 @@
                 <a:ea typeface="Yu Gothic"/>
                 <a:cs typeface="Yu Gothic"/>
               </a:rPr>
-              <a:t xml:space="preserve">図: 常圧（灰）と 120 GPa（紺）の吸収帯。吸収極大とイオン化端が同時に青へ動き、120 GPa では σ(473) が σ(532) の </a:t>
-            </a:r>
-            <a:r>
-              <a:rPr sz="1800" b="1">
+              <a:t xml:space="preserve">吸収極大とイオン化端が同時に青へ動き、120 GPa では σ(473) が σ(532) の </a:t>
+            </a:r>
+            <a:r>
+              <a:rPr sz="2000" b="1">
                 <a:solidFill>
                   <a:srgbClr val="101426"/>
                 </a:solidFill>
@@ -11208,7 +11219,7 @@
               <a:t>10 倍</a:t>
             </a:r>
             <a:r>
-              <a:rPr sz="1800" b="0">
+              <a:rPr sz="2000" b="0">
                 <a:solidFill>
                   <a:srgbClr val="101426"/>
                 </a:solidFill>
@@ -11216,7 +11227,7 @@
                 <a:ea typeface="Yu Gothic"/>
                 <a:cs typeface="Yu Gothic"/>
               </a:rPr>
-              <a:t>になる。常圧曲線は単一有効フォノン近似で、50 GPa 以下では粗い。</a:t>
+              <a:t>になる。</a:t>
             </a:r>
           </a:p>
         </p:txBody>
@@ -11612,7 +11623,7 @@
         <p:spPr>
           <a:xfrm>
             <a:off x="7726679" y="3246120"/>
-            <a:ext cx="3977639" cy="1965960"/>
+            <a:ext cx="3977639" cy="2286000"/>
           </a:xfrm>
           <a:prstGeom prst="rect">
             <a:avLst/>
@@ -11763,8 +11774,8 @@
         </p:nvSpPr>
         <p:spPr>
           <a:xfrm>
-            <a:off x="502920" y="5358384"/>
-            <a:ext cx="11192256" cy="868680"/>
+            <a:off x="502920" y="5715000"/>
+            <a:ext cx="11192256" cy="411480"/>
           </a:xfrm>
           <a:prstGeom prst="rect">
             <a:avLst/>
@@ -11786,7 +11797,7 @@
               </a:spcAft>
             </a:pPr>
             <a:r>
-              <a:rPr sz="1800" b="0">
+              <a:rPr sz="2000" b="0">
                 <a:solidFill>
                   <a:srgbClr val="101426"/>
                 </a:solidFill>
@@ -11794,10 +11805,10 @@
                 <a:ea typeface="Yu Gothic"/>
                 <a:cs typeface="Yu Gothic"/>
               </a:rPr>
-              <a:t>図: 帯は入力の MC 16–84%。λopt = 475.5 +5.6 / −5.3 nm は 5% 許容窓 463–488 nm の半分を占める。</a:t>
-            </a:r>
-            <a:r>
-              <a:rPr sz="1800" b="1">
+              <a:t xml:space="preserve">λopt の不確かさ ±5.5 nm は 5% 許容窓の半分を占める — </a:t>
+            </a:r>
+            <a:r>
+              <a:rPr sz="2000" b="1">
                 <a:solidFill>
                   <a:srgbClr val="101426"/>
                 </a:solidFill>
@@ -11805,7 +11816,18 @@
                 <a:ea typeface="Yu Gothic"/>
                 <a:cs typeface="Yu Gothic"/>
               </a:rPr>
-              <a:t>市販の 473 nm DPSS はその窓の中で、最適の 0.2% 落ちにすぎない。</a:t>
+              <a:t>答えは点ではなく窓である</a:t>
+            </a:r>
+            <a:r>
+              <a:rPr sz="2000" b="0">
+                <a:solidFill>
+                  <a:srgbClr val="101426"/>
+                </a:solidFill>
+                <a:latin typeface="Yu Gothic"/>
+                <a:ea typeface="Yu Gothic"/>
+                <a:cs typeface="Yu Gothic"/>
+              </a:rPr>
+              <a:t>。</a:t>
             </a:r>
           </a:p>
         </p:txBody>
@@ -11890,7 +11912,7 @@
         <p:spPr>
           <a:xfrm>
             <a:off x="7726679" y="1371600"/>
-            <a:ext cx="3977639" cy="3840480"/>
+            <a:ext cx="3977639" cy="4160520"/>
           </a:xfrm>
           <a:prstGeom prst="rect">
             <a:avLst/>
@@ -12072,7 +12094,7 @@
                 <a:ea typeface="Yu Gothic"/>
                 <a:cs typeface="Yu Gothic"/>
               </a:rPr>
-              <a:t>K. O. Ho, C. Dailledouze et al., arXiv:2606.02399 (2026)。</a:t>
+              <a:t>K. O. Ho, C. Dailledouze et al., arXiv:2606.02399 (2026)。等パワー比較では光子束 ∝ λ なので、最適は σabs 極大 474.0 nm ではなく λσabs 極大 475.5 nm。</a:t>
             </a:r>
           </a:p>
         </p:txBody>
@@ -12085,8 +12107,8 @@
         </p:nvSpPr>
         <p:spPr>
           <a:xfrm>
-            <a:off x="502920" y="5358384"/>
-            <a:ext cx="11192256" cy="868680"/>
+            <a:off x="502920" y="5715000"/>
+            <a:ext cx="11192256" cy="411480"/>
           </a:xfrm>
           <a:prstGeom prst="rect">
             <a:avLst/>
@@ -12108,7 +12130,7 @@
               </a:spcAft>
             </a:pPr>
             <a:r>
-              <a:rPr sz="1800" b="0">
+              <a:rPr sz="2000" b="0">
                 <a:solidFill>
                   <a:srgbClr val="101426"/>
                 </a:solidFill>
@@ -12116,10 +12138,10 @@
                 <a:ea typeface="Yu Gothic"/>
                 <a:cs typeface="Yu Gothic"/>
               </a:rPr>
-              <a:t>図: 各入力を MC 範囲の端に振ったときの λopt の変化。動かすのは光学入力 3 つだけで、</a:t>
-            </a:r>
-            <a:r>
-              <a:rPr sz="1800" b="1">
+              <a:t>動かすのは光学入力 3 つだけで、</a:t>
+            </a:r>
+            <a:r>
+              <a:rPr sz="2000" b="1">
                 <a:solidFill>
                   <a:srgbClr val="101426"/>
                 </a:solidFill>
@@ -12127,10 +12149,10 @@
                 <a:ea typeface="Yu Gothic"/>
                 <a:cs typeface="Yu Gothic"/>
               </a:rPr>
-              <a:t>校正でフィットする現象論定数は 1 つも動かさない</a:t>
-            </a:r>
-            <a:r>
-              <a:rPr sz="1800" b="0">
+              <a:t>校正でフィットする現象論定数は 1 つも λopt を動かさない</a:t>
+            </a:r>
+            <a:r>
+              <a:rPr sz="2000" b="0">
                 <a:solidFill>
                   <a:srgbClr val="101426"/>
                 </a:solidFill>
@@ -12138,7 +12160,7 @@
                 <a:ea typeface="Yu Gothic"/>
                 <a:cs typeface="Yu Gothic"/>
               </a:rPr>
-              <a:t>。等パワー比較では光子束 ∝ λ なので、最適は σabs 極大 474.0 nm ではなく λσabs 極大 475.5 nm。</a:t>
+              <a:t>。</a:t>
             </a:r>
           </a:p>
         </p:txBody>
@@ -12223,7 +12245,7 @@
         <p:spPr>
           <a:xfrm>
             <a:off x="7726679" y="1371600"/>
-            <a:ext cx="3977639" cy="3840480"/>
+            <a:ext cx="3977639" cy="4160520"/>
           </a:xfrm>
           <a:prstGeom prst="rect">
             <a:avLst/>
@@ -12374,8 +12396,8 @@
         </p:nvSpPr>
         <p:spPr>
           <a:xfrm>
-            <a:off x="502920" y="5358384"/>
-            <a:ext cx="11192256" cy="868680"/>
+            <a:off x="502920" y="5715000"/>
+            <a:ext cx="11192256" cy="411480"/>
           </a:xfrm>
           <a:prstGeom prst="rect">
             <a:avLst/>
@@ -12397,7 +12419,7 @@
               </a:spcAft>
             </a:pPr>
             <a:r>
-              <a:rPr sz="1800" b="0">
+              <a:rPr sz="2000" b="0">
                 <a:solidFill>
                   <a:srgbClr val="101426"/>
                 </a:solidFill>
@@ -12405,10 +12427,10 @@
                 <a:ea typeface="Yu Gothic"/>
                 <a:cs typeface="Yu Gothic"/>
               </a:rPr>
-              <a:t>図: 50 GPa の既報は</a:t>
-            </a:r>
-            <a:r>
-              <a:rPr sz="1800" b="1">
+              <a:t>50 GPa の既報が</a:t>
+            </a:r>
+            <a:r>
+              <a:rPr sz="2000" b="1">
                 <a:solidFill>
                   <a:srgbClr val="101426"/>
                 </a:solidFill>
@@ -12416,10 +12438,10 @@
                 <a:ea typeface="Yu Gothic"/>
                 <a:cs typeface="Yu Gothic"/>
               </a:rPr>
-              <a:t>青の優位を見つけなかった</a:t>
-            </a:r>
-            <a:r>
-              <a:rPr sz="1800" b="0">
+              <a:t>青の優位を見つけなかったこと自体</a:t>
+            </a:r>
+            <a:r>
+              <a:rPr sz="2000" b="0">
                 <a:solidFill>
                   <a:srgbClr val="101426"/>
                 </a:solidFill>
@@ -12427,7 +12449,7 @@
                 <a:ea typeface="Yu Gothic"/>
                 <a:cs typeface="Yu Gothic"/>
               </a:rPr>
-              <a:t>。モデルはそこで 0.56、緑が有利と答える。見つからなかったことが再現になっている。</a:t>
+              <a:t>が、モデルの再現になっている。</a:t>
             </a:r>
           </a:p>
         </p:txBody>

</xml_diff>

<commit_message>
Set the foot sentence in navy at 28 pt
The navy band with reversed text was heavier than the sentence needed. The foot
is now navy text on the page, and its size is chosen per slide as the largest
of 28/26/24/22/20 pt that still keeps it on one line.

Fitting to one line at that size is what forced the sentences to get shorter,
and shortening them removed a redundancy worth removing: each foot had been
restating its own slide title. The title keeps the headline, the foot now
carries the number the figure establishes -- x10 at 473 nm, the phenomenological
constants that move nothing, the band that fills half the window, the null
result, the x1.51 penalty. All five land at 28 pt.

Slide 6 cites nothing, so its citation strip is deleted rather than left empty.

Co-Authored-By: Claude Opus 5 <noreply@anthropic.com>
Claude-Session: https://claude.ai/code/session_01G8w5ArMbexSrF5VZNHeNqx
</commit_message>
<xml_diff>
--- a/slides/odmr_473nm_talk.pptx
+++ b/slides/odmr_473nm_talk.pptx
@@ -9615,12 +9615,10 @@
           <a:prstGeom prst="rect">
             <a:avLst/>
           </a:prstGeom>
-          <a:solidFill>
-            <a:srgbClr val="1C3177"/>
-          </a:solidFill>
+          <a:noFill/>
         </p:spPr>
         <p:txBody>
-          <a:bodyPr wrap="square" lIns="164592" rIns="164592" tIns="82296" bIns="82296" anchor="ctr">
+          <a:bodyPr wrap="square" lIns="0" rIns="0" tIns="0" bIns="0" anchor="ctr">
             <a:spAutoFit/>
           </a:bodyPr>
           <a:lstStyle/>
@@ -9634,37 +9632,37 @@
               </a:spcAft>
             </a:pPr>
             <a:r>
-              <a:rPr sz="2000" b="0">
-                <a:solidFill>
-                  <a:srgbClr val="FFFFFF"/>
+              <a:rPr sz="2800" b="0">
+                <a:solidFill>
+                  <a:srgbClr val="1C3177"/>
                 </a:solidFill>
                 <a:latin typeface="Yu Gothic"/>
                 <a:ea typeface="Yu Gothic"/>
                 <a:cs typeface="Yu Gothic"/>
               </a:rPr>
-              <a:t>既存実験がいる u ≲ 0.3 では 473 nm 固定が ×1.51 になり、</a:t>
-            </a:r>
-            <a:r>
-              <a:rPr sz="2000" b="1">
-                <a:solidFill>
-                  <a:srgbClr val="FFFFFF"/>
+              <a:t xml:space="preserve">既存実験がいる u ≲ 0.3 で </a:t>
+            </a:r>
+            <a:r>
+              <a:rPr sz="2800" b="1">
+                <a:solidFill>
+                  <a:srgbClr val="1C3177"/>
                 </a:solidFill>
                 <a:latin typeface="Yu Gothic"/>
                 <a:ea typeface="Yu Gothic"/>
                 <a:cs typeface="Yu Gothic"/>
               </a:rPr>
-              <a:t>緑への ×2.5 の大半を食う</a:t>
-            </a:r>
-            <a:r>
-              <a:rPr sz="2000" b="0">
-                <a:solidFill>
-                  <a:srgbClr val="FFFFFF"/>
+              <a:t>473 nm 固定は ×1.51</a:t>
+            </a:r>
+            <a:r>
+              <a:rPr sz="2800" b="0">
+                <a:solidFill>
+                  <a:srgbClr val="1C3177"/>
                 </a:solidFill>
                 <a:latin typeface="Yu Gothic"/>
                 <a:ea typeface="Yu Gothic"/>
                 <a:cs typeface="Yu Gothic"/>
               </a:rPr>
-              <a:t>。</a:t>
+              <a:t xml:space="preserve"> になる。</a:t>
             </a:r>
           </a:p>
         </p:txBody>
@@ -11193,12 +11191,10 @@
           <a:prstGeom prst="rect">
             <a:avLst/>
           </a:prstGeom>
-          <a:solidFill>
-            <a:srgbClr val="1C3177"/>
-          </a:solidFill>
+          <a:noFill/>
         </p:spPr>
         <p:txBody>
-          <a:bodyPr wrap="square" lIns="164592" rIns="164592" tIns="82296" bIns="82296" anchor="ctr">
+          <a:bodyPr wrap="square" lIns="0" rIns="0" tIns="0" bIns="0" anchor="ctr">
             <a:spAutoFit/>
           </a:bodyPr>
           <a:lstStyle/>
@@ -11212,20 +11208,20 @@
               </a:spcAft>
             </a:pPr>
             <a:r>
-              <a:rPr sz="2000" b="0">
-                <a:solidFill>
-                  <a:srgbClr val="FFFFFF"/>
+              <a:rPr sz="2800" b="0">
+                <a:solidFill>
+                  <a:srgbClr val="1C3177"/>
                 </a:solidFill>
                 <a:latin typeface="Yu Gothic"/>
                 <a:ea typeface="Yu Gothic"/>
                 <a:cs typeface="Yu Gothic"/>
               </a:rPr>
-              <a:t xml:space="preserve">吸収極大とイオン化端が同時に青へ動き、120 GPa では σ(473) が σ(532) の </a:t>
-            </a:r>
-            <a:r>
-              <a:rPr sz="2000" b="1">
-                <a:solidFill>
-                  <a:srgbClr val="FFFFFF"/>
+              <a:t xml:space="preserve">120 GPa では σ(473) が σ(532) の </a:t>
+            </a:r>
+            <a:r>
+              <a:rPr sz="2800" b="1">
+                <a:solidFill>
+                  <a:srgbClr val="1C3177"/>
                 </a:solidFill>
                 <a:latin typeface="Yu Gothic"/>
                 <a:ea typeface="Yu Gothic"/>
@@ -11234,9 +11230,9 @@
               <a:t>10 倍</a:t>
             </a:r>
             <a:r>
-              <a:rPr sz="2000" b="0">
-                <a:solidFill>
-                  <a:srgbClr val="FFFFFF"/>
+              <a:rPr sz="2800" b="0">
+                <a:solidFill>
+                  <a:srgbClr val="1C3177"/>
                 </a:solidFill>
                 <a:latin typeface="Yu Gothic"/>
                 <a:ea typeface="Yu Gothic"/>
@@ -11740,39 +11736,6 @@
       </p:sp>
       <p:sp>
         <p:nvSpPr>
-          <p:cNvPr id="6" name="TextBox 5"/>
-          <p:cNvSpPr txBox="1"/>
-          <p:nvPr/>
-        </p:nvSpPr>
-        <p:spPr>
-          <a:xfrm>
-            <a:off x="502920" y="6327648"/>
-            <a:ext cx="11192256" cy="411480"/>
-          </a:xfrm>
-          <a:prstGeom prst="rect">
-            <a:avLst/>
-          </a:prstGeom>
-          <a:noFill/>
-        </p:spPr>
-        <p:txBody>
-          <a:bodyPr wrap="square" lIns="0" rIns="0" tIns="0" bIns="0">
-            <a:spAutoFit/>
-          </a:bodyPr>
-          <a:lstStyle/>
-          <a:p>
-            <a:pPr>
-              <a:lnSpc>
-                <a:spcPct val="125000"/>
-              </a:lnSpc>
-              <a:spcAft>
-                <a:spcPts val="0"/>
-              </a:spcAft>
-            </a:pPr>
-          </a:p>
-        </p:txBody>
-      </p:sp>
-      <p:sp>
-        <p:nvSpPr>
           <p:cNvPr id="90" name="BottomNote"/>
           <p:cNvSpPr txBox="1"/>
           <p:nvPr/>
@@ -11785,12 +11748,10 @@
           <a:prstGeom prst="rect">
             <a:avLst/>
           </a:prstGeom>
-          <a:solidFill>
-            <a:srgbClr val="1C3177"/>
-          </a:solidFill>
+          <a:noFill/>
         </p:spPr>
         <p:txBody>
-          <a:bodyPr wrap="square" lIns="164592" rIns="164592" tIns="82296" bIns="82296" anchor="ctr">
+          <a:bodyPr wrap="square" lIns="0" rIns="0" tIns="0" bIns="0" anchor="ctr">
             <a:spAutoFit/>
           </a:bodyPr>
           <a:lstStyle/>
@@ -11800,17 +11761,41 @@
                 <a:spcPct val="125000"/>
               </a:lnSpc>
               <a:spcAft>
-                <a:spcPts val="0"/>
+                <a:spcPts val="1000"/>
               </a:spcAft>
             </a:pPr>
             <a:r>
-              <a:t xml:space="preserve">λopt の不確かさ ±5.5 nm は 5% 許容窓の半分を占める — </a:t>
-            </a:r>
-            <a:r>
-              <a:t>答えは点ではなく窓である</a:t>
-            </a:r>
-            <a:r>
-              <a:t>。</a:t>
+              <a:rPr sz="2800" b="0">
+                <a:solidFill>
+                  <a:srgbClr val="1C3177"/>
+                </a:solidFill>
+                <a:latin typeface="Yu Gothic"/>
+                <a:ea typeface="Yu Gothic"/>
+                <a:cs typeface="Yu Gothic"/>
+              </a:rPr>
+              <a:t>λopt の不確かさ ±5.5 nm は</a:t>
+            </a:r>
+            <a:r>
+              <a:rPr sz="2800" b="1">
+                <a:solidFill>
+                  <a:srgbClr val="1C3177"/>
+                </a:solidFill>
+                <a:latin typeface="Yu Gothic"/>
+                <a:ea typeface="Yu Gothic"/>
+                <a:cs typeface="Yu Gothic"/>
+              </a:rPr>
+              <a:t>許容窓の半分</a:t>
+            </a:r>
+            <a:r>
+              <a:rPr sz="2800" b="0">
+                <a:solidFill>
+                  <a:srgbClr val="1C3177"/>
+                </a:solidFill>
+                <a:latin typeface="Yu Gothic"/>
+                <a:ea typeface="Yu Gothic"/>
+                <a:cs typeface="Yu Gothic"/>
+              </a:rPr>
+              <a:t>を占める。</a:t>
             </a:r>
           </a:p>
         </p:txBody>
@@ -12075,12 +12060,10 @@
           <a:prstGeom prst="rect">
             <a:avLst/>
           </a:prstGeom>
-          <a:solidFill>
-            <a:srgbClr val="1C3177"/>
-          </a:solidFill>
+          <a:noFill/>
         </p:spPr>
         <p:txBody>
-          <a:bodyPr wrap="square" lIns="164592" rIns="164592" tIns="82296" bIns="82296" anchor="ctr">
+          <a:bodyPr wrap="square" lIns="0" rIns="0" tIns="0" bIns="0" anchor="ctr">
             <a:spAutoFit/>
           </a:bodyPr>
           <a:lstStyle/>
@@ -12094,37 +12077,15 @@
               </a:spcAft>
             </a:pPr>
             <a:r>
-              <a:rPr sz="2000" b="0">
-                <a:solidFill>
-                  <a:srgbClr val="FFFFFF"/>
+              <a:rPr sz="2800" b="1">
+                <a:solidFill>
+                  <a:srgbClr val="1C3177"/>
                 </a:solidFill>
                 <a:latin typeface="Yu Gothic"/>
                 <a:ea typeface="Yu Gothic"/>
                 <a:cs typeface="Yu Gothic"/>
               </a:rPr>
-              <a:t>動かすのは光学入力 3 つだけで、</a:t>
-            </a:r>
-            <a:r>
-              <a:rPr sz="2000" b="1">
-                <a:solidFill>
-                  <a:srgbClr val="FFFFFF"/>
-                </a:solidFill>
-                <a:latin typeface="Yu Gothic"/>
-                <a:ea typeface="Yu Gothic"/>
-                <a:cs typeface="Yu Gothic"/>
-              </a:rPr>
-              <a:t>校正でフィットする現象論定数は 1 つも λopt を動かさない</a:t>
-            </a:r>
-            <a:r>
-              <a:rPr sz="2000" b="0">
-                <a:solidFill>
-                  <a:srgbClr val="FFFFFF"/>
-                </a:solidFill>
-                <a:latin typeface="Yu Gothic"/>
-                <a:ea typeface="Yu Gothic"/>
-                <a:cs typeface="Yu Gothic"/>
-              </a:rPr>
-              <a:t>。</a:t>
+              <a:t>校正でフィットする現象論定数は 1 つも λopt を動かさない。</a:t>
             </a:r>
           </a:p>
         </p:txBody>
@@ -12366,12 +12327,10 @@
           <a:prstGeom prst="rect">
             <a:avLst/>
           </a:prstGeom>
-          <a:solidFill>
-            <a:srgbClr val="1C3177"/>
-          </a:solidFill>
+          <a:noFill/>
         </p:spPr>
         <p:txBody>
-          <a:bodyPr wrap="square" lIns="164592" rIns="164592" tIns="82296" bIns="82296" anchor="ctr">
+          <a:bodyPr wrap="square" lIns="0" rIns="0" tIns="0" bIns="0" anchor="ctr">
             <a:spAutoFit/>
           </a:bodyPr>
           <a:lstStyle/>
@@ -12385,37 +12344,26 @@
               </a:spcAft>
             </a:pPr>
             <a:r>
-              <a:rPr sz="2000" b="0">
-                <a:solidFill>
-                  <a:srgbClr val="FFFFFF"/>
+              <a:rPr sz="2800" b="1">
+                <a:solidFill>
+                  <a:srgbClr val="1C3177"/>
                 </a:solidFill>
                 <a:latin typeface="Yu Gothic"/>
                 <a:ea typeface="Yu Gothic"/>
                 <a:cs typeface="Yu Gothic"/>
               </a:rPr>
-              <a:t>50 GPa の既報が</a:t>
-            </a:r>
-            <a:r>
-              <a:rPr sz="2000" b="1">
-                <a:solidFill>
-                  <a:srgbClr val="FFFFFF"/>
+              <a:t>青の優位が見つからなかったこと自体</a:t>
+            </a:r>
+            <a:r>
+              <a:rPr sz="2800" b="0">
+                <a:solidFill>
+                  <a:srgbClr val="1C3177"/>
                 </a:solidFill>
                 <a:latin typeface="Yu Gothic"/>
                 <a:ea typeface="Yu Gothic"/>
                 <a:cs typeface="Yu Gothic"/>
               </a:rPr>
-              <a:t>青の優位を見つけなかったこと自体</a:t>
-            </a:r>
-            <a:r>
-              <a:rPr sz="2000" b="0">
-                <a:solidFill>
-                  <a:srgbClr val="FFFFFF"/>
-                </a:solidFill>
-                <a:latin typeface="Yu Gothic"/>
-                <a:ea typeface="Yu Gothic"/>
-                <a:cs typeface="Yu Gothic"/>
-              </a:rPr>
-              <a:t>が、モデルの再現になっている。</a:t>
+              <a:t>が再現である。</a:t>
             </a:r>
           </a:p>
         </p:txBody>

</xml_diff>

<commit_message>
Collapse the tornado and reword the claim it supports
Twelve labelled rows oblige the speaker to explain twelve constants in order to
make a point that only needs their count, so the talk figure now shows the
three inputs that move the optimum and one row standing for the nine that do
not. The bars are 0.86 in tall instead of 0.30 in. The full labelled breakdown
is kept as fig5_tornado_full.png for the supplementary material.

The slide is reworded to match. "現象論定数は一つも動かさない" needs the phrase
"現象論定数" defined first; "答えを決めるのは吸収スペクトルの形だけである" says the same
thing from the other side and needs nothing defined, and the foot -- "形を決める
3 つ以外は、±50% 振っても λopt は動かない" -- is then just a reading of the plot.

Co-Authored-By: Claude Opus 5 <noreply@anthropic.com>
Claude-Session: https://claude.ai/code/session_01G8w5ArMbexSrF5VZNHeNqx
</commit_message>
<xml_diff>
--- a/slides/odmr_473nm_talk.pptx
+++ b/slides/odmr_473nm_talk.pptx
@@ -10787,7 +10787,7 @@
                 <a:ea typeface="Yu Gothic"/>
                 <a:cs typeface="Yu Gothic"/>
               </a:rPr>
-              <a:t>最適波長を動かすのは光学入力だけである</a:t>
+              <a:t>答えを決めるのは吸収スペクトルの形だけである</a:t>
             </a:r>
           </a:p>
         </p:txBody>
@@ -10887,7 +10887,7 @@
                 <a:ea typeface="Yu Gothic"/>
                 <a:cs typeface="Yu Gothic"/>
               </a:rPr>
-              <a:t>最大の ±6.9 nm は測定値ではなく、</a:t>
+              <a:t>形を決める 3 つ以外は、</a:t>
             </a:r>
             <a:r>
               <a:rPr sz="2800" b="1">
@@ -10898,7 +10898,7 @@
                 <a:ea typeface="Yu Gothic"/>
                 <a:cs typeface="Yu Gothic"/>
               </a:rPr>
-              <a:t>我々のモデル形</a:t>
+              <a:t>±50% 振っても λopt は動かない</a:t>
             </a:r>
             <a:r>
               <a:rPr sz="2800" b="0">
@@ -10909,7 +10909,7 @@
                 <a:ea typeface="Yu Gothic"/>
                 <a:cs typeface="Yu Gothic"/>
               </a:rPr>
-              <a:t>である。</a:t>
+              <a:t>。</a:t>
             </a:r>
           </a:p>
         </p:txBody>

</xml_diff>

<commit_message>
Credit two sources the slides were using without citing
Slide 2's table gives CeH9 a transition temperature of 115 K, which is Chen
et al., PRL 127, 117001 (2021); Salke was cited for the same row but is the
synthesis at 80-100 GPa, not the Tc. Slide 9's stress row -- alpha = 0.95 for a
micropillar, 0.56 for a flat culet, and the loss of contrast by 40-50 GPa -- is
Hilberer et al., PRB 107, L220102 (2023), and that slide carried no citation
strip at all; it has one now.

The text-box builder is generalised so a slide can be given a strip it never
had, at 12 pt in the citation grey rather than the 18 pt body navy.

The speaker notes for slide 4 gain the anticipated question about two-photon
excitation, marked minor: it is not worth slide space, but it deserves a
prepared answer.

Co-Authored-By: Claude Opus 5 <noreply@anthropic.com>
Claude-Session: https://claude.ai/code/session_01G8w5ArMbexSrF5VZNHeNqx
</commit_message>
<xml_diff>
--- a/slides/odmr_473nm_talk.pptx
+++ b/slides/odmr_473nm_talk.pptx
@@ -851,7 +851,7 @@
           <a:lstStyle/>
           <a:p>
             <a:r>
-              <a:t>2:20–3:20  2 つの端が窓を挟み込む。常圧曲線は単一有効フォノン近似が粗い旨を先に断る（次ページの伏線）。</a:t>
+              <a:t>2:20–3:20  2 つの端が窓を挟み込む。常圧曲線は単一有効フォノン近似が粗い旨を先に断る（次ページの伏線）。［想定質問・軽微］なぜ二光子励起ではなく青色単光子か: 二光子励起は CW ロックインと両立せず、必要なピーク強度は DAC の熱制約に触れる。本研究は既存の CW-ODMR 装置で波長を替えるだけで得られる利得を扱う。なおモデル内の二光子過程は信号源ではなく、高強度でのイオン化損失としてのみ入っている（8 枚目）。</a:t>
             </a:r>
           </a:p>
         </p:txBody>
@@ -10035,7 +10035,7 @@
                 <a:ea typeface="Yu Gothic"/>
                 <a:cs typeface="Yu Gothic"/>
               </a:rPr>
-              <a:t>Bhattacharyya, PhD thesis (2022) Fig. 2.2; Drozdov, Nature 525, 73 (2015); 569, 528 (2019); Salke, Nat. Commun. 10, 4453 (2019); Bi, ibid. 13, 5952 (2022).</a:t>
+              <a:t>Bhattacharyya, PhD thesis (2022) Fig. 2.2; Drozdov, Nature 525, 73 (2015); 569, 528 (2019); Salke, Nat. Commun. 10, 4453 (2019); Chen, PRL 127, 117001 (2021); Bi, Nat. Commun. 13, 5952 (2022).</a:t>
             </a:r>
           </a:p>
         </p:txBody>
@@ -11531,6 +11531,38 @@
                 <a:cs typeface="Yu Gothic"/>
               </a:rPr>
               <a:t>で撮れる。</a:t>
+            </a:r>
+          </a:p>
+        </p:txBody>
+      </p:sp>
+      <p:sp>
+        <p:nvSpPr>
+          <p:cNvPr id="90" name="RefNote"/>
+          <p:cNvSpPr txBox="1"/>
+          <p:nvPr/>
+        </p:nvSpPr>
+        <p:spPr>
+          <a:xfrm>
+            <a:off x="502920" y="6327648"/>
+            <a:ext cx="11192256" cy="411480"/>
+          </a:xfrm>
+          <a:prstGeom prst="rect"/>
+          <a:noFill/>
+        </p:spPr>
+        <p:txBody>
+          <a:bodyPr wrap="square" lIns="0" rIns="0" tIns="0" bIns="0" anchor="ctr"/>
+          <a:lstStyle/>
+          <a:p>
+            <a:r>
+              <a:rPr sz="1200" b="0">
+                <a:solidFill>
+                  <a:srgbClr val="6E7488"/>
+                </a:solidFill>
+                <a:latin typeface="Yu Gothic"/>
+                <a:ea typeface="Yu Gothic"/>
+                <a:cs typeface="Yu Gothic"/>
+              </a:rPr>
+              <a:t>A. Hilberer et al., Phys. Rev. B 107, L220102 (2023).</a:t>
             </a:r>
           </a:p>
         </p:txBody>

</xml_diff>